<commit_message>
Update notebook and presentation
</commit_message>
<xml_diff>
--- a/docs/DHW2_Wagner_Kryeziu_Johnson.pptx
+++ b/docs/DHW2_Wagner_Kryeziu_Johnson.pptx
@@ -5,7 +5,7 @@
     <p:sldMasterId id="2147483648" r:id="rId1"/>
   </p:sldMasterIdLst>
   <p:notesMasterIdLst>
-    <p:notesMasterId r:id="rId10"/>
+    <p:notesMasterId r:id="rId11"/>
   </p:notesMasterIdLst>
   <p:sldIdLst>
     <p:sldId id="256" r:id="rId2"/>
@@ -15,7 +15,8 @@
     <p:sldId id="260" r:id="rId6"/>
     <p:sldId id="261" r:id="rId7"/>
     <p:sldId id="262" r:id="rId8"/>
-    <p:sldId id="263" r:id="rId9"/>
+    <p:sldId id="264" r:id="rId9"/>
+    <p:sldId id="263" r:id="rId10"/>
   </p:sldIdLst>
   <p:sldSz cx="12192000" cy="6858000"/>
   <p:notesSz cx="6858000" cy="9144000"/>
@@ -4954,14 +4955,15 @@
               </a:ext>
             </a:extLst>
           </a:blip>
+          <a:srcRect b="33950"/>
           <a:stretch>
             <a:fillRect/>
           </a:stretch>
         </p:blipFill>
         <p:spPr>
           <a:xfrm>
-            <a:off x="555476" y="326345"/>
-            <a:ext cx="9075634" cy="6263967"/>
+            <a:off x="555475" y="362440"/>
+            <a:ext cx="10381229" cy="4732561"/>
           </a:xfrm>
           <a:prstGeom prst="rect">
             <a:avLst/>
@@ -5063,7 +5065,288 @@
           <a:bodyPr/>
           <a:lstStyle/>
           <a:p>
-            <a:endParaRPr lang="de-DE"/>
+            <a:r>
+              <a:rPr lang="de-CH" dirty="0"/>
+              <a:t>The 1B </a:t>
+            </a:r>
+            <a:r>
+              <a:rPr lang="de-CH" dirty="0" err="1"/>
+              <a:t>model</a:t>
+            </a:r>
+            <a:r>
+              <a:rPr lang="de-CH" dirty="0"/>
+              <a:t> </a:t>
+            </a:r>
+            <a:r>
+              <a:rPr lang="de-CH" dirty="0" err="1"/>
+              <a:t>fails</a:t>
+            </a:r>
+            <a:r>
+              <a:rPr lang="de-CH" dirty="0"/>
+              <a:t> </a:t>
+            </a:r>
+            <a:r>
+              <a:rPr lang="de-CH" dirty="0" err="1"/>
+              <a:t>almost</a:t>
+            </a:r>
+            <a:r>
+              <a:rPr lang="de-CH" dirty="0"/>
+              <a:t> </a:t>
+            </a:r>
+            <a:r>
+              <a:rPr lang="de-CH" dirty="0" err="1"/>
+              <a:t>entirely</a:t>
+            </a:r>
+            <a:r>
+              <a:rPr lang="de-CH" dirty="0"/>
+              <a:t> at </a:t>
+            </a:r>
+            <a:r>
+              <a:rPr lang="de-CH" dirty="0" err="1"/>
+              <a:t>the</a:t>
+            </a:r>
+            <a:r>
+              <a:rPr lang="de-CH" dirty="0"/>
+              <a:t> </a:t>
+            </a:r>
+            <a:r>
+              <a:rPr lang="de-CH" dirty="0" err="1"/>
+              <a:t>schema</a:t>
+            </a:r>
+            <a:r>
+              <a:rPr lang="de-CH" dirty="0"/>
+              <a:t> </a:t>
+            </a:r>
+            <a:r>
+              <a:rPr lang="de-CH" dirty="0" err="1"/>
+              <a:t>levelWrong</a:t>
+            </a:r>
+            <a:r>
+              <a:rPr lang="de-CH" dirty="0"/>
+              <a:t> </a:t>
+            </a:r>
+            <a:r>
+              <a:rPr lang="de-CH" dirty="0" err="1"/>
+              <a:t>joins</a:t>
+            </a:r>
+            <a:r>
+              <a:rPr lang="de-CH" dirty="0"/>
+              <a:t> and </a:t>
+            </a:r>
+            <a:r>
+              <a:rPr lang="de-CH" dirty="0" err="1"/>
+              <a:t>hallucinated</a:t>
+            </a:r>
+            <a:r>
+              <a:rPr lang="de-CH" dirty="0"/>
+              <a:t> </a:t>
+            </a:r>
+            <a:r>
+              <a:rPr lang="de-CH" dirty="0" err="1"/>
+              <a:t>columns</a:t>
+            </a:r>
+            <a:r>
+              <a:rPr lang="de-CH" dirty="0"/>
+              <a:t> </a:t>
+            </a:r>
+            <a:r>
+              <a:rPr lang="de-CH" dirty="0" err="1"/>
+              <a:t>account</a:t>
+            </a:r>
+            <a:r>
+              <a:rPr lang="de-CH" dirty="0"/>
+              <a:t> </a:t>
+            </a:r>
+            <a:r>
+              <a:rPr lang="de-CH" dirty="0" err="1"/>
+              <a:t>for</a:t>
+            </a:r>
+            <a:r>
+              <a:rPr lang="de-CH" dirty="0"/>
+              <a:t> 11 </a:t>
+            </a:r>
+            <a:r>
+              <a:rPr lang="de-CH" dirty="0" err="1"/>
+              <a:t>of</a:t>
+            </a:r>
+            <a:r>
+              <a:rPr lang="de-CH" dirty="0"/>
+              <a:t> </a:t>
+            </a:r>
+            <a:r>
+              <a:rPr lang="de-CH" dirty="0" err="1"/>
+              <a:t>the</a:t>
+            </a:r>
+            <a:r>
+              <a:rPr lang="de-CH" dirty="0"/>
+              <a:t> 14 </a:t>
+            </a:r>
+            <a:r>
+              <a:rPr lang="de-CH" dirty="0" err="1"/>
+              <a:t>failures</a:t>
+            </a:r>
+            <a:endParaRPr lang="de-CH" dirty="0"/>
+          </a:p>
+          <a:p>
+            <a:pPr lvl="1"/>
+            <a:r>
+              <a:rPr lang="de-CH" dirty="0" err="1"/>
+              <a:t>Accuracy</a:t>
+            </a:r>
+            <a:r>
+              <a:rPr lang="de-CH" dirty="0"/>
+              <a:t> </a:t>
+            </a:r>
+            <a:r>
+              <a:rPr lang="de-CH" dirty="0" err="1"/>
+              <a:t>drops</a:t>
+            </a:r>
+            <a:r>
+              <a:rPr lang="de-CH" dirty="0"/>
+              <a:t> </a:t>
+            </a:r>
+            <a:r>
+              <a:rPr lang="de-CH" dirty="0" err="1"/>
+              <a:t>sharply</a:t>
+            </a:r>
+            <a:r>
+              <a:rPr lang="de-CH" dirty="0"/>
+              <a:t> </a:t>
+            </a:r>
+            <a:r>
+              <a:rPr lang="de-CH" dirty="0" err="1"/>
+              <a:t>with</a:t>
+            </a:r>
+            <a:r>
+              <a:rPr lang="de-CH" dirty="0"/>
+              <a:t> </a:t>
+            </a:r>
+            <a:r>
+              <a:rPr lang="de-CH" dirty="0" err="1"/>
+              <a:t>increasing</a:t>
+            </a:r>
+            <a:r>
+              <a:rPr lang="de-CH" dirty="0"/>
+              <a:t> </a:t>
+            </a:r>
+            <a:r>
+              <a:rPr lang="de-CH" dirty="0" err="1"/>
+              <a:t>difficultyEasy</a:t>
+            </a:r>
+            <a:r>
+              <a:rPr lang="de-CH" dirty="0"/>
+              <a:t>: 67%</a:t>
+            </a:r>
+          </a:p>
+          <a:p>
+            <a:pPr lvl="1"/>
+            <a:r>
+              <a:rPr lang="de-CH" dirty="0"/>
+              <a:t>Extra: 0%</a:t>
+            </a:r>
+          </a:p>
+          <a:p>
+            <a:r>
+              <a:rPr lang="de-CH" dirty="0"/>
+              <a:t>2 </a:t>
+            </a:r>
+            <a:r>
+              <a:rPr lang="de-CH" dirty="0" err="1"/>
+              <a:t>of</a:t>
+            </a:r>
+            <a:r>
+              <a:rPr lang="de-CH" dirty="0"/>
+              <a:t> </a:t>
+            </a:r>
+            <a:r>
+              <a:rPr lang="de-CH" dirty="0" err="1"/>
+              <a:t>the</a:t>
+            </a:r>
+            <a:r>
+              <a:rPr lang="de-CH" dirty="0"/>
+              <a:t> 4 “</a:t>
+            </a:r>
+            <a:r>
+              <a:rPr lang="de-CH" dirty="0" err="1"/>
+              <a:t>correct</a:t>
+            </a:r>
+            <a:r>
+              <a:rPr lang="de-CH" dirty="0"/>
+              <a:t>” </a:t>
+            </a:r>
+            <a:r>
+              <a:rPr lang="de-CH" dirty="0" err="1"/>
+              <a:t>answers</a:t>
+            </a:r>
+            <a:r>
+              <a:rPr lang="de-CH" dirty="0"/>
+              <a:t> </a:t>
+            </a:r>
+            <a:r>
+              <a:rPr lang="de-CH" dirty="0" err="1"/>
+              <a:t>were</a:t>
+            </a:r>
+            <a:r>
+              <a:rPr lang="de-CH" dirty="0"/>
+              <a:t> </a:t>
+            </a:r>
+            <a:r>
+              <a:rPr lang="de-CH" dirty="0" err="1"/>
+              <a:t>only</a:t>
+            </a:r>
+            <a:r>
+              <a:rPr lang="de-CH" dirty="0"/>
+              <a:t> lucky </a:t>
+            </a:r>
+            <a:r>
+              <a:rPr lang="de-CH" dirty="0" err="1"/>
+              <a:t>guessesEffective</a:t>
+            </a:r>
+            <a:r>
+              <a:rPr lang="de-CH" dirty="0"/>
+              <a:t> real </a:t>
+            </a:r>
+            <a:r>
+              <a:rPr lang="de-CH" dirty="0" err="1"/>
+              <a:t>accuracy</a:t>
+            </a:r>
+            <a:r>
+              <a:rPr lang="de-CH" dirty="0"/>
+              <a:t> </a:t>
+            </a:r>
+            <a:r>
+              <a:rPr lang="de-CH" dirty="0" err="1"/>
+              <a:t>is</a:t>
+            </a:r>
+            <a:r>
+              <a:rPr lang="de-CH" dirty="0"/>
+              <a:t> </a:t>
+            </a:r>
+            <a:r>
+              <a:rPr lang="de-CH" dirty="0" err="1"/>
+              <a:t>therefore</a:t>
+            </a:r>
+            <a:r>
+              <a:rPr lang="de-CH" dirty="0"/>
+              <a:t> </a:t>
+            </a:r>
+            <a:r>
+              <a:rPr lang="de-CH" dirty="0" err="1"/>
+              <a:t>closer</a:t>
+            </a:r>
+            <a:r>
+              <a:rPr lang="de-CH" dirty="0"/>
+              <a:t> </a:t>
+            </a:r>
+            <a:r>
+              <a:rPr lang="de-CH" dirty="0" err="1"/>
+              <a:t>to</a:t>
+            </a:r>
+            <a:r>
+              <a:rPr lang="de-CH" dirty="0"/>
+              <a:t> ~11%</a:t>
+            </a:r>
+            <a:endParaRPr lang="de-DE" dirty="0"/>
           </a:p>
         </p:txBody>
       </p:sp>
@@ -5170,7 +5453,7 @@
           <p:cNvPr id="2" name="Titel 1">
             <a:extLst>
               <a:ext uri="{FF2B5EF4-FFF2-40B4-BE49-F238E27FC236}">
-                <a16:creationId xmlns:a16="http://schemas.microsoft.com/office/drawing/2014/main" id="{D8191700-7A1A-EE6D-EAAF-9424295F016E}"/>
+                <a16:creationId xmlns:a16="http://schemas.microsoft.com/office/drawing/2014/main" id="{13D88D8D-742D-C8A4-7308-30A65371334F}"/>
               </a:ext>
             </a:extLst>
           </p:cNvPr>
@@ -5181,12 +5464,141 @@
             <p:ph type="title"/>
           </p:nvPr>
         </p:nvSpPr>
-        <p:spPr/>
+        <p:spPr>
+          <a:xfrm>
+            <a:off x="838200" y="81206"/>
+            <a:ext cx="10515600" cy="1325563"/>
+          </a:xfrm>
+        </p:spPr>
         <p:txBody>
           <a:bodyPr/>
           <a:lstStyle/>
           <a:p>
             <a:r>
+              <a:rPr lang="de-CH" dirty="0" err="1"/>
+              <a:t>Testing</a:t>
+            </a:r>
+            <a:r>
+              <a:rPr lang="de-CH" dirty="0"/>
+              <a:t> </a:t>
+            </a:r>
+            <a:r>
+              <a:rPr lang="de-CH" dirty="0" err="1"/>
+              <a:t>overfitting</a:t>
+            </a:r>
+            <a:r>
+              <a:rPr lang="de-CH" dirty="0"/>
+              <a:t> on </a:t>
+            </a:r>
+            <a:r>
+              <a:rPr lang="de-CH" dirty="0" err="1"/>
+              <a:t>new</a:t>
+            </a:r>
+            <a:r>
+              <a:rPr lang="de-CH" dirty="0"/>
+              <a:t> </a:t>
+            </a:r>
+            <a:r>
+              <a:rPr lang="de-CH" dirty="0" err="1"/>
+              <a:t>test</a:t>
+            </a:r>
+            <a:r>
+              <a:rPr lang="de-CH" dirty="0"/>
+              <a:t> </a:t>
+            </a:r>
+            <a:r>
+              <a:rPr lang="de-CH" dirty="0" err="1"/>
+              <a:t>set</a:t>
+            </a:r>
+            <a:endParaRPr lang="de-DE" dirty="0"/>
+          </a:p>
+        </p:txBody>
+      </p:sp>
+      <p:pic>
+        <p:nvPicPr>
+          <p:cNvPr id="5" name="Inhaltsplatzhalter 4">
+            <a:extLst>
+              <a:ext uri="{FF2B5EF4-FFF2-40B4-BE49-F238E27FC236}">
+                <a16:creationId xmlns:a16="http://schemas.microsoft.com/office/drawing/2014/main" id="{FD7C27D7-D5D1-FDDB-6955-382DE9364D68}"/>
+              </a:ext>
+            </a:extLst>
+          </p:cNvPr>
+          <p:cNvPicPr>
+            <a:picLocks noGrp="1" noChangeAspect="1"/>
+          </p:cNvPicPr>
+          <p:nvPr>
+            <p:ph idx="1"/>
+          </p:nvPr>
+        </p:nvPicPr>
+        <p:blipFill>
+          <a:blip r:embed="rId2"/>
+          <a:srcRect t="7201" b="28304"/>
+          <a:stretch>
+            <a:fillRect/>
+          </a:stretch>
+        </p:blipFill>
+        <p:spPr>
+          <a:xfrm>
+            <a:off x="685800" y="1225061"/>
+            <a:ext cx="10251685" cy="4407877"/>
+          </a:xfrm>
+          <a:prstGeom prst="rect">
+            <a:avLst/>
+          </a:prstGeom>
+        </p:spPr>
+      </p:pic>
+    </p:spTree>
+    <p:extLst>
+      <p:ext uri="{BB962C8B-B14F-4D97-AF65-F5344CB8AC3E}">
+        <p14:creationId xmlns:p14="http://schemas.microsoft.com/office/powerpoint/2010/main" val="1858057628"/>
+      </p:ext>
+    </p:extLst>
+  </p:cSld>
+  <p:clrMapOvr>
+    <a:masterClrMapping/>
+  </p:clrMapOvr>
+</p:sld>
+</file>
+
+<file path=ppt/slides/slide9.xml><?xml version="1.0" encoding="utf-8"?>
+<p:sld xmlns:a="http://schemas.openxmlformats.org/drawingml/2006/main" xmlns:r="http://schemas.openxmlformats.org/officeDocument/2006/relationships" xmlns:p="http://schemas.openxmlformats.org/presentationml/2006/main">
+  <p:cSld>
+    <p:spTree>
+      <p:nvGrpSpPr>
+        <p:cNvPr id="1" name=""/>
+        <p:cNvGrpSpPr/>
+        <p:nvPr/>
+      </p:nvGrpSpPr>
+      <p:grpSpPr>
+        <a:xfrm>
+          <a:off x="0" y="0"/>
+          <a:ext cx="0" cy="0"/>
+          <a:chOff x="0" y="0"/>
+          <a:chExt cx="0" cy="0"/>
+        </a:xfrm>
+      </p:grpSpPr>
+      <p:sp>
+        <p:nvSpPr>
+          <p:cNvPr id="2" name="Titel 1">
+            <a:extLst>
+              <a:ext uri="{FF2B5EF4-FFF2-40B4-BE49-F238E27FC236}">
+                <a16:creationId xmlns:a16="http://schemas.microsoft.com/office/drawing/2014/main" id="{D8191700-7A1A-EE6D-EAAF-9424295F016E}"/>
+              </a:ext>
+            </a:extLst>
+          </p:cNvPr>
+          <p:cNvSpPr>
+            <a:spLocks noGrp="1"/>
+          </p:cNvSpPr>
+          <p:nvPr>
+            <p:ph type="title"/>
+          </p:nvPr>
+        </p:nvSpPr>
+        <p:spPr/>
+        <p:txBody>
+          <a:bodyPr/>
+          <a:lstStyle/>
+          <a:p>
+            <a:r>
               <a:rPr lang="de-DE" dirty="0" err="1"/>
               <a:t>Conclusion</a:t>
             </a:r>
@@ -5223,7 +5635,631 @@
           <a:bodyPr/>
           <a:lstStyle/>
           <a:p>
-            <a:endParaRPr lang="de-DE"/>
+            <a:r>
+              <a:rPr lang="de-DE" dirty="0" err="1"/>
+              <a:t>We</a:t>
+            </a:r>
+            <a:r>
+              <a:rPr lang="de-DE" dirty="0"/>
+              <a:t> </a:t>
+            </a:r>
+            <a:r>
+              <a:rPr lang="de-DE" dirty="0" err="1"/>
+              <a:t>managed</a:t>
+            </a:r>
+            <a:r>
+              <a:rPr lang="de-DE" dirty="0"/>
+              <a:t> </a:t>
+            </a:r>
+            <a:r>
+              <a:rPr lang="de-DE" dirty="0" err="1"/>
+              <a:t>to</a:t>
+            </a:r>
+            <a:r>
+              <a:rPr lang="de-DE" dirty="0"/>
+              <a:t> </a:t>
+            </a:r>
+            <a:r>
+              <a:rPr lang="de-DE" dirty="0" err="1"/>
+              <a:t>adjust</a:t>
+            </a:r>
+            <a:r>
+              <a:rPr lang="de-DE" dirty="0"/>
+              <a:t> </a:t>
+            </a:r>
+            <a:r>
+              <a:rPr lang="de-DE" dirty="0" err="1"/>
+              <a:t>our</a:t>
+            </a:r>
+            <a:r>
+              <a:rPr lang="de-DE" dirty="0"/>
+              <a:t> </a:t>
+            </a:r>
+            <a:r>
+              <a:rPr lang="de-DE" dirty="0" err="1"/>
+              <a:t>model</a:t>
+            </a:r>
+            <a:r>
+              <a:rPr lang="de-DE" dirty="0"/>
+              <a:t> </a:t>
+            </a:r>
+            <a:r>
+              <a:rPr lang="de-DE" dirty="0" err="1"/>
+              <a:t>to</a:t>
+            </a:r>
+            <a:r>
+              <a:rPr lang="de-DE" dirty="0"/>
+              <a:t> </a:t>
+            </a:r>
+            <a:r>
+              <a:rPr lang="de-DE" dirty="0" err="1"/>
+              <a:t>reach</a:t>
+            </a:r>
+            <a:r>
+              <a:rPr lang="de-DE" dirty="0"/>
+              <a:t> a </a:t>
+            </a:r>
+            <a:r>
+              <a:rPr lang="de-DE" dirty="0" err="1"/>
+              <a:t>successrate</a:t>
+            </a:r>
+            <a:r>
+              <a:rPr lang="de-DE" dirty="0"/>
+              <a:t> </a:t>
+            </a:r>
+            <a:r>
+              <a:rPr lang="de-DE" dirty="0" err="1"/>
+              <a:t>of</a:t>
+            </a:r>
+            <a:r>
+              <a:rPr lang="de-DE" dirty="0"/>
+              <a:t> 94% (17/18) </a:t>
+            </a:r>
+            <a:r>
+              <a:rPr lang="de-DE" dirty="0" err="1"/>
+              <a:t>with</a:t>
+            </a:r>
+            <a:r>
+              <a:rPr lang="de-DE" dirty="0"/>
+              <a:t> a </a:t>
+            </a:r>
+            <a:r>
+              <a:rPr lang="de-DE" dirty="0" err="1"/>
+              <a:t>start</a:t>
+            </a:r>
+            <a:r>
+              <a:rPr lang="de-DE" dirty="0"/>
+              <a:t> </a:t>
+            </a:r>
+            <a:r>
+              <a:rPr lang="de-DE" dirty="0" err="1"/>
+              <a:t>of</a:t>
+            </a:r>
+            <a:r>
+              <a:rPr lang="de-DE" dirty="0"/>
+              <a:t> 22% (4/18). The </a:t>
+            </a:r>
+            <a:r>
+              <a:rPr lang="de-DE" dirty="0" err="1"/>
+              <a:t>strongest</a:t>
+            </a:r>
+            <a:r>
+              <a:rPr lang="de-DE" dirty="0"/>
+              <a:t> </a:t>
+            </a:r>
+            <a:r>
+              <a:rPr lang="de-DE" dirty="0" err="1"/>
+              <a:t>impact</a:t>
+            </a:r>
+            <a:r>
+              <a:rPr lang="de-DE" dirty="0"/>
+              <a:t> was </a:t>
+            </a:r>
+            <a:r>
+              <a:rPr lang="de-DE" dirty="0" err="1"/>
+              <a:t>from</a:t>
+            </a:r>
+            <a:r>
+              <a:rPr lang="de-DE" dirty="0"/>
+              <a:t> </a:t>
+            </a:r>
+            <a:r>
+              <a:rPr lang="de-DE" dirty="0" err="1"/>
+              <a:t>describing</a:t>
+            </a:r>
+            <a:r>
+              <a:rPr lang="de-DE" dirty="0"/>
+              <a:t> </a:t>
+            </a:r>
+            <a:r>
+              <a:rPr lang="de-DE" dirty="0" err="1"/>
+              <a:t>the</a:t>
+            </a:r>
+            <a:r>
+              <a:rPr lang="de-DE" dirty="0"/>
+              <a:t> </a:t>
+            </a:r>
+            <a:r>
+              <a:rPr lang="de-DE" dirty="0" err="1"/>
+              <a:t>tables</a:t>
+            </a:r>
+            <a:r>
+              <a:rPr lang="de-DE" dirty="0"/>
+              <a:t> </a:t>
+            </a:r>
+            <a:r>
+              <a:rPr lang="de-DE" dirty="0" err="1"/>
+              <a:t>to</a:t>
+            </a:r>
+            <a:r>
+              <a:rPr lang="de-DE" dirty="0"/>
+              <a:t> </a:t>
+            </a:r>
+            <a:r>
+              <a:rPr lang="de-DE" dirty="0" err="1"/>
+              <a:t>the</a:t>
+            </a:r>
+            <a:r>
+              <a:rPr lang="de-DE" dirty="0"/>
+              <a:t> </a:t>
+            </a:r>
+            <a:r>
+              <a:rPr lang="de-DE" dirty="0" err="1"/>
+              <a:t>model</a:t>
+            </a:r>
+            <a:r>
+              <a:rPr lang="de-DE" dirty="0"/>
+              <a:t> and </a:t>
+            </a:r>
+            <a:r>
+              <a:rPr lang="de-DE" dirty="0" err="1"/>
+              <a:t>adjusting</a:t>
+            </a:r>
+            <a:r>
+              <a:rPr lang="de-DE" dirty="0"/>
+              <a:t> </a:t>
+            </a:r>
+            <a:r>
+              <a:rPr lang="de-DE" dirty="0" err="1"/>
+              <a:t>the</a:t>
+            </a:r>
+            <a:r>
+              <a:rPr lang="de-DE" dirty="0"/>
+              <a:t> </a:t>
+            </a:r>
+            <a:r>
+              <a:rPr lang="de-DE" dirty="0" err="1"/>
+              <a:t>model</a:t>
+            </a:r>
+            <a:r>
+              <a:rPr lang="de-DE" dirty="0"/>
+              <a:t> </a:t>
+            </a:r>
+            <a:r>
+              <a:rPr lang="de-DE" dirty="0" err="1"/>
+              <a:t>from</a:t>
+            </a:r>
+            <a:r>
+              <a:rPr lang="de-DE" dirty="0"/>
+              <a:t> </a:t>
+            </a:r>
+            <a:r>
+              <a:rPr lang="de-DE" dirty="0" err="1"/>
+              <a:t>llama</a:t>
+            </a:r>
+            <a:r>
+              <a:rPr lang="de-DE" dirty="0"/>
+              <a:t> </a:t>
+            </a:r>
+            <a:r>
+              <a:rPr lang="de-DE" dirty="0" err="1"/>
+              <a:t>to</a:t>
+            </a:r>
+            <a:r>
+              <a:rPr lang="de-DE" dirty="0"/>
+              <a:t> </a:t>
+            </a:r>
+            <a:r>
+              <a:rPr lang="de-DE" dirty="0" err="1"/>
+              <a:t>qwen</a:t>
+            </a:r>
+            <a:r>
+              <a:rPr lang="de-DE" dirty="0"/>
+              <a:t>. </a:t>
+            </a:r>
+            <a:r>
+              <a:rPr lang="de-DE" dirty="0" err="1"/>
+              <a:t>We</a:t>
+            </a:r>
+            <a:r>
+              <a:rPr lang="de-DE" dirty="0"/>
+              <a:t> </a:t>
+            </a:r>
+            <a:r>
+              <a:rPr lang="de-DE" dirty="0" err="1"/>
+              <a:t>wanted</a:t>
+            </a:r>
+            <a:r>
+              <a:rPr lang="de-DE" dirty="0"/>
+              <a:t> </a:t>
+            </a:r>
+            <a:r>
+              <a:rPr lang="de-DE" dirty="0" err="1"/>
+              <a:t>to</a:t>
+            </a:r>
+            <a:r>
+              <a:rPr lang="de-DE" dirty="0"/>
+              <a:t> </a:t>
+            </a:r>
+            <a:r>
+              <a:rPr lang="de-DE" dirty="0" err="1"/>
+              <a:t>prove</a:t>
+            </a:r>
+            <a:r>
+              <a:rPr lang="de-DE" dirty="0"/>
+              <a:t> </a:t>
+            </a:r>
+            <a:r>
+              <a:rPr lang="de-DE" dirty="0" err="1"/>
+              <a:t>that</a:t>
+            </a:r>
+            <a:r>
+              <a:rPr lang="de-DE" dirty="0"/>
+              <a:t> </a:t>
+            </a:r>
+            <a:r>
+              <a:rPr lang="de-DE" dirty="0" err="1"/>
+              <a:t>our</a:t>
+            </a:r>
+            <a:r>
+              <a:rPr lang="de-DE" dirty="0"/>
+              <a:t> </a:t>
+            </a:r>
+            <a:r>
+              <a:rPr lang="de-DE" dirty="0" err="1"/>
+              <a:t>model</a:t>
+            </a:r>
+            <a:r>
+              <a:rPr lang="de-DE" dirty="0"/>
+              <a:t> </a:t>
+            </a:r>
+            <a:r>
+              <a:rPr lang="de-DE" dirty="0" err="1"/>
+              <a:t>is</a:t>
+            </a:r>
+            <a:r>
+              <a:rPr lang="de-DE" dirty="0"/>
+              <a:t> not </a:t>
+            </a:r>
+            <a:r>
+              <a:rPr lang="de-DE" dirty="0" err="1"/>
+              <a:t>completly</a:t>
+            </a:r>
+            <a:r>
+              <a:rPr lang="de-DE" dirty="0"/>
+              <a:t> </a:t>
+            </a:r>
+            <a:r>
+              <a:rPr lang="de-DE" dirty="0" err="1"/>
+              <a:t>overfitting</a:t>
+            </a:r>
+            <a:r>
+              <a:rPr lang="de-DE" dirty="0"/>
+              <a:t> </a:t>
+            </a:r>
+            <a:r>
+              <a:rPr lang="de-DE" dirty="0" err="1"/>
+              <a:t>to</a:t>
+            </a:r>
+            <a:r>
+              <a:rPr lang="de-DE" dirty="0"/>
+              <a:t> </a:t>
+            </a:r>
+            <a:r>
+              <a:rPr lang="de-DE" dirty="0" err="1"/>
+              <a:t>the</a:t>
+            </a:r>
+            <a:r>
+              <a:rPr lang="de-DE" dirty="0"/>
+              <a:t> </a:t>
+            </a:r>
+            <a:r>
+              <a:rPr lang="de-DE" dirty="0" err="1"/>
+              <a:t>questions</a:t>
+            </a:r>
+            <a:r>
+              <a:rPr lang="de-DE" dirty="0"/>
+              <a:t> </a:t>
+            </a:r>
+            <a:r>
+              <a:rPr lang="de-DE" dirty="0" err="1"/>
+              <a:t>we</a:t>
+            </a:r>
+            <a:r>
+              <a:rPr lang="de-DE" dirty="0"/>
+              <a:t> </a:t>
+            </a:r>
+            <a:r>
+              <a:rPr lang="de-DE" dirty="0" err="1"/>
+              <a:t>optimezed</a:t>
+            </a:r>
+            <a:r>
+              <a:rPr lang="de-DE" dirty="0"/>
+              <a:t> </a:t>
+            </a:r>
+            <a:r>
+              <a:rPr lang="de-DE" dirty="0" err="1"/>
+              <a:t>it</a:t>
+            </a:r>
+            <a:r>
+              <a:rPr lang="de-DE" dirty="0"/>
+              <a:t> on and </a:t>
+            </a:r>
+            <a:r>
+              <a:rPr lang="de-DE" dirty="0" err="1"/>
+              <a:t>it</a:t>
+            </a:r>
+            <a:r>
+              <a:rPr lang="de-DE" dirty="0"/>
+              <a:t> </a:t>
+            </a:r>
+            <a:r>
+              <a:rPr lang="de-DE" dirty="0" err="1"/>
+              <a:t>reached</a:t>
+            </a:r>
+            <a:r>
+              <a:rPr lang="de-DE" dirty="0"/>
+              <a:t> 50% (9/18) </a:t>
+            </a:r>
+            <a:r>
+              <a:rPr lang="de-DE" dirty="0" err="1"/>
+              <a:t>which</a:t>
+            </a:r>
+            <a:r>
+              <a:rPr lang="de-DE" dirty="0"/>
+              <a:t> </a:t>
+            </a:r>
+            <a:r>
+              <a:rPr lang="de-DE" dirty="0" err="1"/>
+              <a:t>means</a:t>
+            </a:r>
+            <a:r>
+              <a:rPr lang="de-DE" dirty="0"/>
+              <a:t> </a:t>
+            </a:r>
+            <a:r>
+              <a:rPr lang="de-DE" dirty="0" err="1"/>
+              <a:t>it</a:t>
+            </a:r>
+            <a:r>
+              <a:rPr lang="de-DE" dirty="0"/>
+              <a:t> </a:t>
+            </a:r>
+            <a:r>
+              <a:rPr lang="de-DE" dirty="0" err="1"/>
+              <a:t>is</a:t>
+            </a:r>
+            <a:r>
+              <a:rPr lang="de-DE" dirty="0"/>
+              <a:t> not </a:t>
+            </a:r>
+            <a:r>
+              <a:rPr lang="de-DE" dirty="0" err="1"/>
+              <a:t>generalizing</a:t>
+            </a:r>
+            <a:r>
+              <a:rPr lang="de-DE" dirty="0"/>
+              <a:t> </a:t>
+            </a:r>
+            <a:r>
+              <a:rPr lang="de-DE" dirty="0" err="1"/>
+              <a:t>that</a:t>
+            </a:r>
+            <a:r>
+              <a:rPr lang="de-DE" dirty="0"/>
+              <a:t> </a:t>
+            </a:r>
+            <a:r>
+              <a:rPr lang="de-DE" dirty="0" err="1"/>
+              <a:t>well</a:t>
+            </a:r>
+            <a:r>
+              <a:rPr lang="de-DE" dirty="0"/>
+              <a:t>.</a:t>
+            </a:r>
+          </a:p>
+          <a:p>
+            <a:endParaRPr lang="de-DE" dirty="0"/>
+          </a:p>
+          <a:p>
+            <a:r>
+              <a:rPr lang="de-DE" dirty="0"/>
+              <a:t>In </a:t>
+            </a:r>
+            <a:r>
+              <a:rPr lang="de-DE" dirty="0" err="1"/>
+              <a:t>the</a:t>
+            </a:r>
+            <a:r>
+              <a:rPr lang="de-DE" dirty="0"/>
+              <a:t> </a:t>
+            </a:r>
+            <a:r>
+              <a:rPr lang="de-DE" dirty="0" err="1"/>
+              <a:t>future</a:t>
+            </a:r>
+            <a:r>
+              <a:rPr lang="de-DE" dirty="0"/>
+              <a:t> </a:t>
+            </a:r>
+            <a:r>
+              <a:rPr lang="de-DE" dirty="0" err="1"/>
+              <a:t>we</a:t>
+            </a:r>
+            <a:r>
+              <a:rPr lang="de-DE" dirty="0"/>
+              <a:t> </a:t>
+            </a:r>
+            <a:r>
+              <a:rPr lang="de-DE" dirty="0" err="1"/>
+              <a:t>would</a:t>
+            </a:r>
+            <a:r>
+              <a:rPr lang="de-DE" dirty="0"/>
+              <a:t> like </a:t>
+            </a:r>
+            <a:r>
+              <a:rPr lang="de-DE" dirty="0" err="1"/>
+              <a:t>to</a:t>
+            </a:r>
+            <a:r>
+              <a:rPr lang="de-DE" dirty="0"/>
+              <a:t> </a:t>
+            </a:r>
+            <a:r>
+              <a:rPr lang="de-DE" dirty="0" err="1"/>
+              <a:t>optimize</a:t>
+            </a:r>
+            <a:r>
+              <a:rPr lang="de-DE" dirty="0"/>
+              <a:t> on </a:t>
+            </a:r>
+            <a:r>
+              <a:rPr lang="de-DE" dirty="0" err="1"/>
+              <a:t>parameters</a:t>
+            </a:r>
+            <a:r>
+              <a:rPr lang="de-DE" dirty="0"/>
+              <a:t> </a:t>
+            </a:r>
+            <a:r>
+              <a:rPr lang="de-DE" dirty="0" err="1"/>
+              <a:t>that</a:t>
+            </a:r>
+            <a:r>
+              <a:rPr lang="de-DE" dirty="0"/>
+              <a:t> </a:t>
+            </a:r>
+            <a:r>
+              <a:rPr lang="de-DE" dirty="0" err="1"/>
+              <a:t>are</a:t>
+            </a:r>
+            <a:r>
+              <a:rPr lang="de-DE" dirty="0"/>
+              <a:t> </a:t>
+            </a:r>
+            <a:r>
+              <a:rPr lang="de-DE" dirty="0" err="1"/>
+              <a:t>generalizing</a:t>
+            </a:r>
+            <a:r>
+              <a:rPr lang="de-DE" dirty="0"/>
+              <a:t>, </a:t>
+            </a:r>
+            <a:r>
+              <a:rPr lang="de-DE" dirty="0" err="1"/>
+              <a:t>meaning</a:t>
+            </a:r>
+            <a:r>
+              <a:rPr lang="de-DE" dirty="0"/>
+              <a:t> </a:t>
+            </a:r>
+            <a:r>
+              <a:rPr lang="de-DE" dirty="0" err="1"/>
+              <a:t>to</a:t>
+            </a:r>
+            <a:r>
+              <a:rPr lang="de-DE" dirty="0"/>
+              <a:t> </a:t>
+            </a:r>
+            <a:r>
+              <a:rPr lang="de-DE" dirty="0" err="1"/>
+              <a:t>evaluate</a:t>
+            </a:r>
+            <a:r>
+              <a:rPr lang="de-DE" dirty="0"/>
+              <a:t> different </a:t>
+            </a:r>
+            <a:r>
+              <a:rPr lang="de-DE" dirty="0" err="1"/>
+              <a:t>test</a:t>
+            </a:r>
+            <a:r>
+              <a:rPr lang="de-DE" dirty="0"/>
+              <a:t> </a:t>
+            </a:r>
+            <a:r>
+              <a:rPr lang="de-DE" dirty="0" err="1"/>
+              <a:t>sets</a:t>
+            </a:r>
+            <a:r>
+              <a:rPr lang="de-DE" dirty="0"/>
+              <a:t> at </a:t>
+            </a:r>
+            <a:r>
+              <a:rPr lang="de-DE" dirty="0" err="1"/>
+              <a:t>the</a:t>
+            </a:r>
+            <a:r>
+              <a:rPr lang="de-DE" dirty="0"/>
+              <a:t> same time </a:t>
+            </a:r>
+            <a:r>
+              <a:rPr lang="de-DE" dirty="0" err="1"/>
+              <a:t>to</a:t>
+            </a:r>
+            <a:r>
+              <a:rPr lang="de-DE" dirty="0"/>
+              <a:t> check </a:t>
+            </a:r>
+            <a:r>
+              <a:rPr lang="de-DE" dirty="0" err="1"/>
+              <a:t>if</a:t>
+            </a:r>
+            <a:r>
+              <a:rPr lang="de-DE" dirty="0"/>
+              <a:t> </a:t>
+            </a:r>
+            <a:r>
+              <a:rPr lang="de-DE" dirty="0" err="1"/>
+              <a:t>we</a:t>
+            </a:r>
+            <a:r>
+              <a:rPr lang="de-DE" dirty="0"/>
+              <a:t> </a:t>
+            </a:r>
+            <a:r>
+              <a:rPr lang="de-DE" dirty="0" err="1"/>
+              <a:t>reached</a:t>
+            </a:r>
+            <a:r>
+              <a:rPr lang="de-DE" dirty="0"/>
+              <a:t> </a:t>
+            </a:r>
+            <a:r>
+              <a:rPr lang="de-DE" dirty="0" err="1"/>
+              <a:t>better</a:t>
+            </a:r>
+            <a:r>
+              <a:rPr lang="de-DE" dirty="0"/>
+              <a:t> </a:t>
+            </a:r>
+            <a:r>
+              <a:rPr lang="de-DE" dirty="0" err="1"/>
+              <a:t>scores</a:t>
+            </a:r>
+            <a:r>
+              <a:rPr lang="de-DE" dirty="0"/>
+              <a:t> in </a:t>
+            </a:r>
+            <a:r>
+              <a:rPr lang="de-DE" dirty="0" err="1"/>
+              <a:t>general</a:t>
+            </a:r>
+            <a:r>
+              <a:rPr lang="de-DE" dirty="0"/>
+              <a:t>.</a:t>
+            </a:r>
           </a:p>
         </p:txBody>
       </p:sp>

</xml_diff>